<commit_message>
Mise à jour de la piste de scores
</commit_message>
<xml_diff>
--- a/pictures/Piste-Scores/Design-Piste-Scores.pptx
+++ b/pictures/Piste-Scores/Design-Piste-Scores.pptx
@@ -198,7 +198,7 @@
           <a:p>
             <a:fld id="{263B0988-6DB9-4E3D-B7FD-EFF3BCABE954}" type="datetimeFigureOut">
               <a:rPr lang="fr-FR" smtClean="0"/>
-              <a:t>15/03/2026</a:t>
+              <a:t>06/04/2026</a:t>
             </a:fld>
             <a:endParaRPr lang="fr-FR"/>
           </a:p>
@@ -465,6 +465,90 @@
 </p:notesMaster>
 </file>
 
+<file path=ppt/notesSlides/notesSlide1.xml><?xml version="1.0" encoding="utf-8"?>
+<p:notes xmlns:a="http://schemas.openxmlformats.org/drawingml/2006/main" xmlns:r="http://schemas.openxmlformats.org/officeDocument/2006/relationships" xmlns:p="http://schemas.openxmlformats.org/presentationml/2006/main">
+  <p:cSld>
+    <p:spTree>
+      <p:nvGrpSpPr>
+        <p:cNvPr id="1" name=""/>
+        <p:cNvGrpSpPr/>
+        <p:nvPr/>
+      </p:nvGrpSpPr>
+      <p:grpSpPr>
+        <a:xfrm>
+          <a:off x="0" y="0"/>
+          <a:ext cx="0" cy="0"/>
+          <a:chOff x="0" y="0"/>
+          <a:chExt cx="0" cy="0"/>
+        </a:xfrm>
+      </p:grpSpPr>
+      <p:sp>
+        <p:nvSpPr>
+          <p:cNvPr id="2" name="Espace réservé de l'image des diapositives 1"/>
+          <p:cNvSpPr>
+            <a:spLocks noGrp="1" noRot="1" noChangeAspect="1"/>
+          </p:cNvSpPr>
+          <p:nvPr>
+            <p:ph type="sldImg"/>
+          </p:nvPr>
+        </p:nvSpPr>
+        <p:spPr/>
+      </p:sp>
+      <p:sp>
+        <p:nvSpPr>
+          <p:cNvPr id="3" name="Espace réservé des notes 2"/>
+          <p:cNvSpPr>
+            <a:spLocks noGrp="1"/>
+          </p:cNvSpPr>
+          <p:nvPr>
+            <p:ph type="body" idx="1"/>
+          </p:nvPr>
+        </p:nvSpPr>
+        <p:spPr/>
+        <p:txBody>
+          <a:bodyPr/>
+          <a:lstStyle/>
+          <a:p>
+            <a:endParaRPr lang="fr-FR" dirty="0"/>
+          </a:p>
+        </p:txBody>
+      </p:sp>
+      <p:sp>
+        <p:nvSpPr>
+          <p:cNvPr id="4" name="Espace réservé du numéro de diapositive 3"/>
+          <p:cNvSpPr>
+            <a:spLocks noGrp="1"/>
+          </p:cNvSpPr>
+          <p:nvPr>
+            <p:ph type="sldNum" sz="quarter" idx="5"/>
+          </p:nvPr>
+        </p:nvSpPr>
+        <p:spPr/>
+        <p:txBody>
+          <a:bodyPr/>
+          <a:lstStyle/>
+          <a:p>
+            <a:fld id="{D3B0DD9D-2173-49B3-B084-704F33D21705}" type="slidenum">
+              <a:rPr lang="fr-FR" smtClean="0"/>
+              <a:t>1</a:t>
+            </a:fld>
+            <a:endParaRPr lang="fr-FR"/>
+          </a:p>
+        </p:txBody>
+      </p:sp>
+    </p:spTree>
+    <p:extLst>
+      <p:ext uri="{BB962C8B-B14F-4D97-AF65-F5344CB8AC3E}">
+        <p14:creationId xmlns:p14="http://schemas.microsoft.com/office/powerpoint/2010/main" val="1725745680"/>
+      </p:ext>
+    </p:extLst>
+  </p:cSld>
+  <p:clrMapOvr>
+    <a:masterClrMapping/>
+  </p:clrMapOvr>
+</p:notes>
+</file>
+
 <file path=ppt/slideLayouts/slideLayout1.xml><?xml version="1.0" encoding="utf-8"?>
 <p:sldLayout xmlns:a="http://schemas.openxmlformats.org/drawingml/2006/main" xmlns:r="http://schemas.openxmlformats.org/officeDocument/2006/relationships" xmlns:p="http://schemas.openxmlformats.org/presentationml/2006/main" type="title" preserve="1">
   <p:cSld name="Diapositive de titre">
@@ -612,7 +696,7 @@
           <a:p>
             <a:fld id="{588505E2-0C4C-443F-8F57-41958F504CA2}" type="datetimeFigureOut">
               <a:rPr lang="fr-FR" smtClean="0"/>
-              <a:t>15/03/2026</a:t>
+              <a:t>06/04/2026</a:t>
             </a:fld>
             <a:endParaRPr lang="fr-FR"/>
           </a:p>
@@ -810,7 +894,7 @@
           <a:p>
             <a:fld id="{588505E2-0C4C-443F-8F57-41958F504CA2}" type="datetimeFigureOut">
               <a:rPr lang="fr-FR" smtClean="0"/>
-              <a:t>15/03/2026</a:t>
+              <a:t>06/04/2026</a:t>
             </a:fld>
             <a:endParaRPr lang="fr-FR"/>
           </a:p>
@@ -1018,7 +1102,7 @@
           <a:p>
             <a:fld id="{588505E2-0C4C-443F-8F57-41958F504CA2}" type="datetimeFigureOut">
               <a:rPr lang="fr-FR" smtClean="0"/>
-              <a:t>15/03/2026</a:t>
+              <a:t>06/04/2026</a:t>
             </a:fld>
             <a:endParaRPr lang="fr-FR"/>
           </a:p>
@@ -1216,7 +1300,7 @@
           <a:p>
             <a:fld id="{588505E2-0C4C-443F-8F57-41958F504CA2}" type="datetimeFigureOut">
               <a:rPr lang="fr-FR" smtClean="0"/>
-              <a:t>15/03/2026</a:t>
+              <a:t>06/04/2026</a:t>
             </a:fld>
             <a:endParaRPr lang="fr-FR"/>
           </a:p>
@@ -1491,7 +1575,7 @@
           <a:p>
             <a:fld id="{588505E2-0C4C-443F-8F57-41958F504CA2}" type="datetimeFigureOut">
               <a:rPr lang="fr-FR" smtClean="0"/>
-              <a:t>15/03/2026</a:t>
+              <a:t>06/04/2026</a:t>
             </a:fld>
             <a:endParaRPr lang="fr-FR"/>
           </a:p>
@@ -1756,7 +1840,7 @@
           <a:p>
             <a:fld id="{588505E2-0C4C-443F-8F57-41958F504CA2}" type="datetimeFigureOut">
               <a:rPr lang="fr-FR" smtClean="0"/>
-              <a:t>15/03/2026</a:t>
+              <a:t>06/04/2026</a:t>
             </a:fld>
             <a:endParaRPr lang="fr-FR"/>
           </a:p>
@@ -2168,7 +2252,7 @@
           <a:p>
             <a:fld id="{588505E2-0C4C-443F-8F57-41958F504CA2}" type="datetimeFigureOut">
               <a:rPr lang="fr-FR" smtClean="0"/>
-              <a:t>15/03/2026</a:t>
+              <a:t>06/04/2026</a:t>
             </a:fld>
             <a:endParaRPr lang="fr-FR"/>
           </a:p>
@@ -2309,7 +2393,7 @@
           <a:p>
             <a:fld id="{588505E2-0C4C-443F-8F57-41958F504CA2}" type="datetimeFigureOut">
               <a:rPr lang="fr-FR" smtClean="0"/>
-              <a:t>15/03/2026</a:t>
+              <a:t>06/04/2026</a:t>
             </a:fld>
             <a:endParaRPr lang="fr-FR"/>
           </a:p>
@@ -2422,7 +2506,7 @@
           <a:p>
             <a:fld id="{588505E2-0C4C-443F-8F57-41958F504CA2}" type="datetimeFigureOut">
               <a:rPr lang="fr-FR" smtClean="0"/>
-              <a:t>15/03/2026</a:t>
+              <a:t>06/04/2026</a:t>
             </a:fld>
             <a:endParaRPr lang="fr-FR"/>
           </a:p>
@@ -2733,7 +2817,7 @@
           <a:p>
             <a:fld id="{588505E2-0C4C-443F-8F57-41958F504CA2}" type="datetimeFigureOut">
               <a:rPr lang="fr-FR" smtClean="0"/>
-              <a:t>15/03/2026</a:t>
+              <a:t>06/04/2026</a:t>
             </a:fld>
             <a:endParaRPr lang="fr-FR"/>
           </a:p>
@@ -3021,7 +3105,7 @@
           <a:p>
             <a:fld id="{588505E2-0C4C-443F-8F57-41958F504CA2}" type="datetimeFigureOut">
               <a:rPr lang="fr-FR" smtClean="0"/>
-              <a:t>15/03/2026</a:t>
+              <a:t>06/04/2026</a:t>
             </a:fld>
             <a:endParaRPr lang="fr-FR"/>
           </a:p>
@@ -3262,7 +3346,7 @@
           <a:p>
             <a:fld id="{588505E2-0C4C-443F-8F57-41958F504CA2}" type="datetimeFigureOut">
               <a:rPr lang="fr-FR" smtClean="0"/>
-              <a:t>15/03/2026</a:t>
+              <a:t>06/04/2026</a:t>
             </a:fld>
             <a:endParaRPr lang="fr-FR"/>
           </a:p>
@@ -3687,10 +3771,10 @@
       </p:grpSpPr>
       <p:grpSp>
         <p:nvGrpSpPr>
-          <p:cNvPr id="3" name="Groupe 2">
+          <p:cNvPr id="12" name="Groupe 11">
             <a:extLst>
               <a:ext uri="{FF2B5EF4-FFF2-40B4-BE49-F238E27FC236}">
-                <a16:creationId xmlns:a16="http://schemas.microsoft.com/office/drawing/2014/main" id="{5853B23E-C92D-60FE-79B3-2CC7802867EC}"/>
+                <a16:creationId xmlns:a16="http://schemas.microsoft.com/office/drawing/2014/main" id="{2E40BB44-66DC-7D3E-DC30-2C241F3E36C3}"/>
               </a:ext>
             </a:extLst>
           </p:cNvPr>
@@ -3699,10 +3783,10 @@
         </p:nvGrpSpPr>
         <p:grpSpPr>
           <a:xfrm>
-            <a:off x="2316000" y="909000"/>
-            <a:ext cx="7560000" cy="5040000"/>
-            <a:chOff x="2316000" y="909000"/>
-            <a:chExt cx="7560000" cy="5040000"/>
+            <a:off x="2156460" y="878520"/>
+            <a:ext cx="7920000" cy="5040000"/>
+            <a:chOff x="2156460" y="878520"/>
+            <a:chExt cx="7920000" cy="5040000"/>
           </a:xfrm>
         </p:grpSpPr>
         <p:sp>
@@ -3719,14 +3803,14 @@
           </p:nvSpPr>
           <p:spPr>
             <a:xfrm>
-              <a:off x="2316000" y="909000"/>
-              <a:ext cx="7560000" cy="5040000"/>
+              <a:off x="2156460" y="878520"/>
+              <a:ext cx="7920000" cy="5040000"/>
             </a:xfrm>
             <a:prstGeom prst="rect">
               <a:avLst/>
             </a:prstGeom>
             <a:blipFill>
-              <a:blip r:embed="rId2"/>
+              <a:blip r:embed="rId3"/>
               <a:tile tx="0" ty="0" sx="100000" sy="100000" flip="none" algn="tl"/>
             </a:blipFill>
             <a:ln w="9525">
@@ -3792,11 +3876,11 @@
               <a:avLst/>
             </a:prstGeom>
             <a:blipFill>
-              <a:blip r:embed="rId3">
+              <a:blip r:embed="rId4">
                 <a:extLst>
                   <a:ext uri="{BEBA8EAE-BF5A-486C-A8C5-ECC9F3942E4B}">
                     <a14:imgProps xmlns:a14="http://schemas.microsoft.com/office/drawing/2010/main">
-                      <a14:imgLayer r:embed="rId4">
+                      <a14:imgLayer r:embed="rId5">
                         <a14:imgEffect>
                           <a14:artisticWatercolorSponge/>
                         </a14:imgEffect>
@@ -3886,7 +3970,7 @@
           </p:nvSpPr>
           <p:spPr>
             <a:xfrm>
-              <a:off x="2813734" y="2336499"/>
+              <a:off x="2813734" y="2080613"/>
               <a:ext cx="492125" cy="466725"/>
             </a:xfrm>
             <a:prstGeom prst="cube">
@@ -3895,11 +3979,11 @@
               </a:avLst>
             </a:prstGeom>
             <a:blipFill>
-              <a:blip r:embed="rId5">
+              <a:blip r:embed="rId6">
                 <a:extLst>
                   <a:ext uri="{BEBA8EAE-BF5A-486C-A8C5-ECC9F3942E4B}">
                     <a14:imgProps xmlns:a14="http://schemas.microsoft.com/office/drawing/2010/main">
-                      <a14:imgLayer r:embed="rId6">
+                      <a14:imgLayer r:embed="rId7">
                         <a14:imgEffect>
                           <a14:artisticPastelsSmooth/>
                         </a14:imgEffect>
@@ -3982,7 +4066,7 @@
           </p:nvSpPr>
           <p:spPr>
             <a:xfrm>
-              <a:off x="2813734" y="2909258"/>
+              <a:off x="2813734" y="2653372"/>
               <a:ext cx="491490" cy="466725"/>
             </a:xfrm>
             <a:prstGeom prst="cube">
@@ -3991,11 +4075,11 @@
               </a:avLst>
             </a:prstGeom>
             <a:blipFill>
-              <a:blip r:embed="rId7">
+              <a:blip r:embed="rId8">
                 <a:extLst>
                   <a:ext uri="{BEBA8EAE-BF5A-486C-A8C5-ECC9F3942E4B}">
                     <a14:imgProps xmlns:a14="http://schemas.microsoft.com/office/drawing/2010/main">
-                      <a14:imgLayer r:embed="rId8">
+                      <a14:imgLayer r:embed="rId9">
                         <a14:imgEffect>
                           <a14:artisticCutout/>
                         </a14:imgEffect>
@@ -4078,7 +4162,7 @@
           </p:nvSpPr>
           <p:spPr>
             <a:xfrm>
-              <a:off x="2572700" y="3482017"/>
+              <a:off x="2572700" y="3226131"/>
               <a:ext cx="973558" cy="852837"/>
             </a:xfrm>
             <a:prstGeom prst="hexagon">
@@ -4088,7 +4172,7 @@
               </a:avLst>
             </a:prstGeom>
             <a:blipFill>
-              <a:blip r:embed="rId9">
+              <a:blip r:embed="rId10">
                 <a:duotone>
                   <a:prstClr val="black"/>
                   <a:schemeClr val="accent1">
@@ -4211,11 +4295,11 @@
               <a:avLst/>
             </a:prstGeom>
             <a:blipFill>
-              <a:blip r:embed="rId3">
+              <a:blip r:embed="rId4">
                 <a:extLst>
                   <a:ext uri="{BEBA8EAE-BF5A-486C-A8C5-ECC9F3942E4B}">
                     <a14:imgProps xmlns:a14="http://schemas.microsoft.com/office/drawing/2010/main">
-                      <a14:imgLayer r:embed="rId4">
+                      <a14:imgLayer r:embed="rId5">
                         <a14:imgEffect>
                           <a14:artisticWatercolorSponge/>
                         </a14:imgEffect>
@@ -4320,11 +4404,11 @@
               <a:avLst/>
             </a:prstGeom>
             <a:blipFill>
-              <a:blip r:embed="rId3">
+              <a:blip r:embed="rId4">
                 <a:extLst>
                   <a:ext uri="{BEBA8EAE-BF5A-486C-A8C5-ECC9F3942E4B}">
                     <a14:imgProps xmlns:a14="http://schemas.microsoft.com/office/drawing/2010/main">
-                      <a14:imgLayer r:embed="rId4">
+                      <a14:imgLayer r:embed="rId5">
                         <a14:imgEffect>
                           <a14:artisticWatercolorSponge/>
                         </a14:imgEffect>
@@ -4429,11 +4513,11 @@
               <a:avLst/>
             </a:prstGeom>
             <a:blipFill>
-              <a:blip r:embed="rId3">
+              <a:blip r:embed="rId4">
                 <a:extLst>
                   <a:ext uri="{BEBA8EAE-BF5A-486C-A8C5-ECC9F3942E4B}">
                     <a14:imgProps xmlns:a14="http://schemas.microsoft.com/office/drawing/2010/main">
-                      <a14:imgLayer r:embed="rId4">
+                      <a14:imgLayer r:embed="rId5">
                         <a14:imgEffect>
                           <a14:artisticWatercolorSponge/>
                         </a14:imgEffect>
@@ -4538,11 +4622,11 @@
               <a:avLst/>
             </a:prstGeom>
             <a:blipFill>
-              <a:blip r:embed="rId3">
+              <a:blip r:embed="rId4">
                 <a:extLst>
                   <a:ext uri="{BEBA8EAE-BF5A-486C-A8C5-ECC9F3942E4B}">
                     <a14:imgProps xmlns:a14="http://schemas.microsoft.com/office/drawing/2010/main">
-                      <a14:imgLayer r:embed="rId4">
+                      <a14:imgLayer r:embed="rId5">
                         <a14:imgEffect>
                           <a14:artisticWatercolorSponge/>
                         </a14:imgEffect>
@@ -4647,11 +4731,11 @@
               <a:avLst/>
             </a:prstGeom>
             <a:blipFill>
-              <a:blip r:embed="rId3">
+              <a:blip r:embed="rId4">
                 <a:extLst>
                   <a:ext uri="{BEBA8EAE-BF5A-486C-A8C5-ECC9F3942E4B}">
                     <a14:imgProps xmlns:a14="http://schemas.microsoft.com/office/drawing/2010/main">
-                      <a14:imgLayer r:embed="rId4">
+                      <a14:imgLayer r:embed="rId5">
                         <a14:imgEffect>
                           <a14:artisticWatercolorSponge/>
                         </a14:imgEffect>
@@ -4756,11 +4840,11 @@
               <a:avLst/>
             </a:prstGeom>
             <a:blipFill>
-              <a:blip r:embed="rId3">
+              <a:blip r:embed="rId4">
                 <a:extLst>
                   <a:ext uri="{BEBA8EAE-BF5A-486C-A8C5-ECC9F3942E4B}">
                     <a14:imgProps xmlns:a14="http://schemas.microsoft.com/office/drawing/2010/main">
-                      <a14:imgLayer r:embed="rId4">
+                      <a14:imgLayer r:embed="rId5">
                         <a14:imgEffect>
                           <a14:artisticWatercolorSponge/>
                         </a14:imgEffect>
@@ -4865,11 +4949,11 @@
               <a:avLst/>
             </a:prstGeom>
             <a:blipFill>
-              <a:blip r:embed="rId3">
+              <a:blip r:embed="rId4">
                 <a:extLst>
                   <a:ext uri="{BEBA8EAE-BF5A-486C-A8C5-ECC9F3942E4B}">
                     <a14:imgProps xmlns:a14="http://schemas.microsoft.com/office/drawing/2010/main">
-                      <a14:imgLayer r:embed="rId4">
+                      <a14:imgLayer r:embed="rId5">
                         <a14:imgEffect>
                           <a14:artisticWatercolorSponge/>
                         </a14:imgEffect>
@@ -4974,11 +5058,11 @@
               <a:avLst/>
             </a:prstGeom>
             <a:blipFill>
-              <a:blip r:embed="rId3">
+              <a:blip r:embed="rId4">
                 <a:extLst>
                   <a:ext uri="{BEBA8EAE-BF5A-486C-A8C5-ECC9F3942E4B}">
                     <a14:imgProps xmlns:a14="http://schemas.microsoft.com/office/drawing/2010/main">
-                      <a14:imgLayer r:embed="rId4">
+                      <a14:imgLayer r:embed="rId5">
                         <a14:imgEffect>
                           <a14:artisticWatercolorSponge/>
                         </a14:imgEffect>
@@ -5083,11 +5167,11 @@
               <a:avLst/>
             </a:prstGeom>
             <a:blipFill>
-              <a:blip r:embed="rId3">
+              <a:blip r:embed="rId4">
                 <a:extLst>
                   <a:ext uri="{BEBA8EAE-BF5A-486C-A8C5-ECC9F3942E4B}">
                     <a14:imgProps xmlns:a14="http://schemas.microsoft.com/office/drawing/2010/main">
-                      <a14:imgLayer r:embed="rId4">
+                      <a14:imgLayer r:embed="rId5">
                         <a14:imgEffect>
                           <a14:artisticWatercolorSponge/>
                         </a14:imgEffect>
@@ -5192,11 +5276,11 @@
               <a:avLst/>
             </a:prstGeom>
             <a:blipFill>
-              <a:blip r:embed="rId3">
+              <a:blip r:embed="rId4">
                 <a:extLst>
                   <a:ext uri="{BEBA8EAE-BF5A-486C-A8C5-ECC9F3942E4B}">
                     <a14:imgProps xmlns:a14="http://schemas.microsoft.com/office/drawing/2010/main">
-                      <a14:imgLayer r:embed="rId4">
+                      <a14:imgLayer r:embed="rId5">
                         <a14:imgEffect>
                           <a14:artisticWatercolorSponge/>
                         </a14:imgEffect>
@@ -5274,104 +5358,6 @@
         </p:sp>
         <p:sp>
           <p:nvSpPr>
-            <p:cNvPr id="147" name="Rectangle 146">
-              <a:extLst>
-                <a:ext uri="{FF2B5EF4-FFF2-40B4-BE49-F238E27FC236}">
-                  <a16:creationId xmlns:a16="http://schemas.microsoft.com/office/drawing/2014/main" id="{993696D2-AB5B-AFF5-5984-623544EDEF1B}"/>
-                </a:ext>
-              </a:extLst>
-            </p:cNvPr>
-            <p:cNvSpPr/>
-            <p:nvPr/>
-          </p:nvSpPr>
-          <p:spPr>
-            <a:xfrm>
-              <a:off x="5135159" y="3458436"/>
-              <a:ext cx="900000" cy="900000"/>
-            </a:xfrm>
-            <a:prstGeom prst="rect">
-              <a:avLst/>
-            </a:prstGeom>
-            <a:blipFill>
-              <a:blip r:embed="rId10">
-                <a:extLst>
-                  <a:ext uri="{BEBA8EAE-BF5A-486C-A8C5-ECC9F3942E4B}">
-                    <a14:imgProps xmlns:a14="http://schemas.microsoft.com/office/drawing/2010/main">
-                      <a14:imgLayer r:embed="rId11">
-                        <a14:imgEffect>
-                          <a14:artisticPaintBrush/>
-                        </a14:imgEffect>
-                      </a14:imgLayer>
-                    </a14:imgProps>
-                  </a:ext>
-                </a:extLst>
-              </a:blip>
-              <a:tile tx="0" ty="0" sx="100000" sy="100000" flip="none" algn="tl"/>
-            </a:blipFill>
-            <a:ln w="19050">
-              <a:solidFill>
-                <a:schemeClr val="bg1"/>
-              </a:solidFill>
-            </a:ln>
-            <a:scene3d>
-              <a:camera prst="orthographicFront"/>
-              <a:lightRig rig="threePt" dir="t"/>
-            </a:scene3d>
-            <a:sp3d>
-              <a:bevelT/>
-            </a:sp3d>
-          </p:spPr>
-          <p:style>
-            <a:lnRef idx="2">
-              <a:schemeClr val="accent1">
-                <a:shade val="15000"/>
-              </a:schemeClr>
-            </a:lnRef>
-            <a:fillRef idx="1">
-              <a:schemeClr val="accent1"/>
-            </a:fillRef>
-            <a:effectRef idx="0">
-              <a:schemeClr val="accent1"/>
-            </a:effectRef>
-            <a:fontRef idx="minor">
-              <a:schemeClr val="lt1"/>
-            </a:fontRef>
-          </p:style>
-          <p:txBody>
-            <a:bodyPr rot="0" spcFirstLastPara="0" vert="horz" wrap="square" lIns="91440" tIns="45720" rIns="91440" bIns="45720" numCol="1" spcCol="0" rtlCol="0" fromWordArt="0" anchor="t" anchorCtr="0" forceAA="0" compatLnSpc="1">
-              <a:prstTxWarp prst="textNoShape">
-                <a:avLst/>
-              </a:prstTxWarp>
-              <a:noAutofit/>
-            </a:bodyPr>
-            <a:lstStyle/>
-            <a:p>
-              <a:pPr algn="ctr">
-                <a:lnSpc>
-                  <a:spcPct val="107000"/>
-                </a:lnSpc>
-                <a:spcAft>
-                  <a:spcPts val="800"/>
-                </a:spcAft>
-                <a:buNone/>
-              </a:pPr>
-              <a:r>
-                <a:rPr lang="fr-FR" sz="1400" b="1" dirty="0">
-                  <a:solidFill>
-                    <a:schemeClr val="tx1"/>
-                  </a:solidFill>
-                  <a:effectLst/>
-                  <a:latin typeface="Segoe UI" panose="020B0502040204020203" pitchFamily="34" charset="0"/>
-                  <a:ea typeface="Aptos" panose="020B0004020202020204" pitchFamily="34" charset="0"/>
-                  <a:cs typeface="Segoe UI" panose="020B0502040204020203" pitchFamily="34" charset="0"/>
-                </a:rPr>
-                <a:t>12</a:t>
-              </a:r>
-            </a:p>
-          </p:txBody>
-        </p:sp>
-        <p:sp>
-          <p:nvSpPr>
             <p:cNvPr id="148" name="Rectangle 147">
               <a:extLst>
                 <a:ext uri="{FF2B5EF4-FFF2-40B4-BE49-F238E27FC236}">
@@ -5391,11 +5377,11 @@
               <a:avLst/>
             </a:prstGeom>
             <a:blipFill>
-              <a:blip r:embed="rId3">
+              <a:blip r:embed="rId4">
                 <a:extLst>
                   <a:ext uri="{BEBA8EAE-BF5A-486C-A8C5-ECC9F3942E4B}">
                     <a14:imgProps xmlns:a14="http://schemas.microsoft.com/office/drawing/2010/main">
-                      <a14:imgLayer r:embed="rId4">
+                      <a14:imgLayer r:embed="rId5">
                         <a14:imgEffect>
                           <a14:artisticWatercolorSponge/>
                         </a14:imgEffect>
@@ -5473,104 +5459,6 @@
         </p:sp>
         <p:sp>
           <p:nvSpPr>
-            <p:cNvPr id="149" name="Rectangle 148">
-              <a:extLst>
-                <a:ext uri="{FF2B5EF4-FFF2-40B4-BE49-F238E27FC236}">
-                  <a16:creationId xmlns:a16="http://schemas.microsoft.com/office/drawing/2014/main" id="{FDB779C8-202E-B522-53A8-D7184A20C4AC}"/>
-                </a:ext>
-              </a:extLst>
-            </p:cNvPr>
-            <p:cNvSpPr/>
-            <p:nvPr/>
-          </p:nvSpPr>
-          <p:spPr>
-            <a:xfrm>
-              <a:off x="7435046" y="3458436"/>
-              <a:ext cx="900000" cy="900000"/>
-            </a:xfrm>
-            <a:prstGeom prst="rect">
-              <a:avLst/>
-            </a:prstGeom>
-            <a:blipFill>
-              <a:blip r:embed="rId10">
-                <a:extLst>
-                  <a:ext uri="{BEBA8EAE-BF5A-486C-A8C5-ECC9F3942E4B}">
-                    <a14:imgProps xmlns:a14="http://schemas.microsoft.com/office/drawing/2010/main">
-                      <a14:imgLayer r:embed="rId11">
-                        <a14:imgEffect>
-                          <a14:artisticPaintBrush/>
-                        </a14:imgEffect>
-                      </a14:imgLayer>
-                    </a14:imgProps>
-                  </a:ext>
-                </a:extLst>
-              </a:blip>
-              <a:tile tx="0" ty="0" sx="100000" sy="100000" flip="none" algn="tl"/>
-            </a:blipFill>
-            <a:ln w="19050">
-              <a:solidFill>
-                <a:schemeClr val="bg1"/>
-              </a:solidFill>
-            </a:ln>
-            <a:scene3d>
-              <a:camera prst="orthographicFront"/>
-              <a:lightRig rig="threePt" dir="t"/>
-            </a:scene3d>
-            <a:sp3d>
-              <a:bevelT/>
-            </a:sp3d>
-          </p:spPr>
-          <p:style>
-            <a:lnRef idx="2">
-              <a:schemeClr val="accent1">
-                <a:shade val="15000"/>
-              </a:schemeClr>
-            </a:lnRef>
-            <a:fillRef idx="1">
-              <a:schemeClr val="accent1"/>
-            </a:fillRef>
-            <a:effectRef idx="0">
-              <a:schemeClr val="accent1"/>
-            </a:effectRef>
-            <a:fontRef idx="minor">
-              <a:schemeClr val="lt1"/>
-            </a:fontRef>
-          </p:style>
-          <p:txBody>
-            <a:bodyPr rot="0" spcFirstLastPara="0" vert="horz" wrap="square" lIns="91440" tIns="45720" rIns="91440" bIns="45720" numCol="1" spcCol="0" rtlCol="0" fromWordArt="0" anchor="t" anchorCtr="0" forceAA="0" compatLnSpc="1">
-              <a:prstTxWarp prst="textNoShape">
-                <a:avLst/>
-              </a:prstTxWarp>
-              <a:noAutofit/>
-            </a:bodyPr>
-            <a:lstStyle/>
-            <a:p>
-              <a:pPr algn="ctr">
-                <a:lnSpc>
-                  <a:spcPct val="107000"/>
-                </a:lnSpc>
-                <a:spcAft>
-                  <a:spcPts val="800"/>
-                </a:spcAft>
-                <a:buNone/>
-              </a:pPr>
-              <a:r>
-                <a:rPr lang="fr-FR" sz="1400" b="1" dirty="0">
-                  <a:solidFill>
-                    <a:schemeClr val="tx1"/>
-                  </a:solidFill>
-                  <a:effectLst/>
-                  <a:latin typeface="Segoe UI" panose="020B0502040204020203" pitchFamily="34" charset="0"/>
-                  <a:ea typeface="Aptos" panose="020B0004020202020204" pitchFamily="34" charset="0"/>
-                  <a:cs typeface="Segoe UI" panose="020B0502040204020203" pitchFamily="34" charset="0"/>
-                </a:rPr>
-                <a:t>14</a:t>
-              </a:r>
-            </a:p>
-          </p:txBody>
-        </p:sp>
-        <p:sp>
-          <p:nvSpPr>
             <p:cNvPr id="150" name="Rectangle 149">
               <a:extLst>
                 <a:ext uri="{FF2B5EF4-FFF2-40B4-BE49-F238E27FC236}">
@@ -5590,11 +5478,11 @@
               <a:avLst/>
             </a:prstGeom>
             <a:blipFill>
-              <a:blip r:embed="rId3">
+              <a:blip r:embed="rId4">
                 <a:extLst>
                   <a:ext uri="{BEBA8EAE-BF5A-486C-A8C5-ECC9F3942E4B}">
                     <a14:imgProps xmlns:a14="http://schemas.microsoft.com/office/drawing/2010/main">
-                      <a14:imgLayer r:embed="rId4">
+                      <a14:imgLayer r:embed="rId5">
                         <a14:imgEffect>
                           <a14:artisticWatercolorSponge/>
                         </a14:imgEffect>
@@ -5691,11 +5579,11 @@
               <a:avLst/>
             </a:prstGeom>
             <a:blipFill>
-              <a:blip r:embed="rId3">
+              <a:blip r:embed="rId4">
                 <a:extLst>
                   <a:ext uri="{BEBA8EAE-BF5A-486C-A8C5-ECC9F3942E4B}">
                     <a14:imgProps xmlns:a14="http://schemas.microsoft.com/office/drawing/2010/main">
-                      <a14:imgLayer r:embed="rId4">
+                      <a14:imgLayer r:embed="rId5">
                         <a14:imgEffect>
                           <a14:artisticWatercolorSponge/>
                         </a14:imgEffect>
@@ -5800,11 +5688,11 @@
               <a:avLst/>
             </a:prstGeom>
             <a:blipFill>
-              <a:blip r:embed="rId3">
+              <a:blip r:embed="rId4">
                 <a:extLst>
                   <a:ext uri="{BEBA8EAE-BF5A-486C-A8C5-ECC9F3942E4B}">
                     <a14:imgProps xmlns:a14="http://schemas.microsoft.com/office/drawing/2010/main">
-                      <a14:imgLayer r:embed="rId4">
+                      <a14:imgLayer r:embed="rId5">
                         <a14:imgEffect>
                           <a14:artisticWatercolorSponge/>
                         </a14:imgEffect>
@@ -5882,92 +5770,6 @@
         </p:sp>
         <p:sp>
           <p:nvSpPr>
-            <p:cNvPr id="154" name="Rectangle 153">
-              <a:extLst>
-                <a:ext uri="{FF2B5EF4-FFF2-40B4-BE49-F238E27FC236}">
-                  <a16:creationId xmlns:a16="http://schemas.microsoft.com/office/drawing/2014/main" id="{1ECBCC94-1927-06D1-45F4-E653A80F3AF3}"/>
-                </a:ext>
-              </a:extLst>
-            </p:cNvPr>
-            <p:cNvSpPr/>
-            <p:nvPr/>
-          </p:nvSpPr>
-          <p:spPr>
-            <a:xfrm>
-              <a:off x="6296418" y="4660439"/>
-              <a:ext cx="900000" cy="900000"/>
-            </a:xfrm>
-            <a:prstGeom prst="rect">
-              <a:avLst/>
-            </a:prstGeom>
-            <a:blipFill>
-              <a:blip r:embed="rId12"/>
-              <a:tile tx="0" ty="0" sx="100000" sy="100000" flip="none" algn="tl"/>
-            </a:blipFill>
-            <a:ln w="19050">
-              <a:solidFill>
-                <a:schemeClr val="bg1"/>
-              </a:solidFill>
-            </a:ln>
-            <a:scene3d>
-              <a:camera prst="orthographicFront"/>
-              <a:lightRig rig="threePt" dir="t"/>
-            </a:scene3d>
-            <a:sp3d>
-              <a:bevelT/>
-            </a:sp3d>
-          </p:spPr>
-          <p:style>
-            <a:lnRef idx="2">
-              <a:schemeClr val="accent1">
-                <a:shade val="15000"/>
-              </a:schemeClr>
-            </a:lnRef>
-            <a:fillRef idx="1">
-              <a:schemeClr val="accent1"/>
-            </a:fillRef>
-            <a:effectRef idx="0">
-              <a:schemeClr val="accent1"/>
-            </a:effectRef>
-            <a:fontRef idx="minor">
-              <a:schemeClr val="lt1"/>
-            </a:fontRef>
-          </p:style>
-          <p:txBody>
-            <a:bodyPr rot="0" spcFirstLastPara="0" vert="horz" wrap="square" lIns="91440" tIns="45720" rIns="91440" bIns="45720" numCol="1" spcCol="0" rtlCol="0" fromWordArt="0" anchor="t" anchorCtr="0" forceAA="0" compatLnSpc="1">
-              <a:prstTxWarp prst="textNoShape">
-                <a:avLst/>
-              </a:prstTxWarp>
-              <a:noAutofit/>
-            </a:bodyPr>
-            <a:lstStyle/>
-            <a:p>
-              <a:pPr algn="ctr">
-                <a:lnSpc>
-                  <a:spcPct val="107000"/>
-                </a:lnSpc>
-                <a:spcAft>
-                  <a:spcPts val="800"/>
-                </a:spcAft>
-                <a:buNone/>
-              </a:pPr>
-              <a:r>
-                <a:rPr lang="fr-FR" sz="1400" b="1" dirty="0">
-                  <a:solidFill>
-                    <a:schemeClr val="tx1"/>
-                  </a:solidFill>
-                  <a:effectLst/>
-                  <a:latin typeface="Segoe UI" panose="020B0502040204020203" pitchFamily="34" charset="0"/>
-                  <a:ea typeface="Aptos" panose="020B0004020202020204" pitchFamily="34" charset="0"/>
-                  <a:cs typeface="Segoe UI" panose="020B0502040204020203" pitchFamily="34" charset="0"/>
-                </a:rPr>
-                <a:t>18</a:t>
-              </a:r>
-            </a:p>
-          </p:txBody>
-        </p:sp>
-        <p:sp>
-          <p:nvSpPr>
             <p:cNvPr id="155" name="Rectangle 154">
               <a:extLst>
                 <a:ext uri="{FF2B5EF4-FFF2-40B4-BE49-F238E27FC236}">
@@ -5987,11 +5789,11 @@
               <a:avLst/>
             </a:prstGeom>
             <a:blipFill>
-              <a:blip r:embed="rId3">
+              <a:blip r:embed="rId4">
                 <a:extLst>
                   <a:ext uri="{BEBA8EAE-BF5A-486C-A8C5-ECC9F3942E4B}">
                     <a14:imgProps xmlns:a14="http://schemas.microsoft.com/office/drawing/2010/main">
-                      <a14:imgLayer r:embed="rId4">
+                      <a14:imgLayer r:embed="rId5">
                         <a14:imgEffect>
                           <a14:artisticWatercolorSponge/>
                         </a14:imgEffect>
@@ -6088,11 +5890,11 @@
               <a:avLst/>
             </a:prstGeom>
             <a:blipFill>
-              <a:blip r:embed="rId3">
+              <a:blip r:embed="rId4">
                 <a:extLst>
                   <a:ext uri="{BEBA8EAE-BF5A-486C-A8C5-ECC9F3942E4B}">
                     <a14:imgProps xmlns:a14="http://schemas.microsoft.com/office/drawing/2010/main">
-                      <a14:imgLayer r:embed="rId4">
+                      <a14:imgLayer r:embed="rId5">
                         <a14:imgEffect>
                           <a14:artisticWatercolorSponge/>
                         </a14:imgEffect>
@@ -7029,330 +6831,675 @@
             </a:fontRef>
           </p:style>
         </p:cxnSp>
-        <p:pic>
-          <p:nvPicPr>
-            <p:cNvPr id="218" name="Graphique 22" descr="Pion avec un remplissage uni">
+        <p:grpSp>
+          <p:nvGrpSpPr>
+            <p:cNvPr id="8" name="Groupe 7">
               <a:extLst>
                 <a:ext uri="{FF2B5EF4-FFF2-40B4-BE49-F238E27FC236}">
-                  <a16:creationId xmlns:a16="http://schemas.microsoft.com/office/drawing/2014/main" id="{EDEB36CE-ABAB-21F8-5E53-B3CE5E1E974B}"/>
+                  <a16:creationId xmlns:a16="http://schemas.microsoft.com/office/drawing/2014/main" id="{B6457E2F-8BCE-B5F9-AAE3-2949356CDED1}"/>
                 </a:ext>
               </a:extLst>
             </p:cNvPr>
-            <p:cNvPicPr>
-              <a:picLocks noChangeAspect="1"/>
-            </p:cNvPicPr>
+            <p:cNvGrpSpPr/>
             <p:nvPr/>
-          </p:nvPicPr>
-          <p:blipFill>
-            <a:blip r:embed="rId13">
-              <a:extLst>
-                <a:ext uri="{96DAC541-7B7A-43D3-8B79-37D633B846F1}">
-                  <asvg:svgBlip xmlns:asvg="http://schemas.microsoft.com/office/drawing/2016/SVG/main" r:embed="rId14"/>
-                </a:ext>
-              </a:extLst>
-            </a:blip>
-            <a:stretch>
-              <a:fillRect/>
-            </a:stretch>
-          </p:blipFill>
-          <p:spPr>
+          </p:nvGrpSpPr>
+          <p:grpSpPr>
             <a:xfrm>
-              <a:off x="6516377" y="5226761"/>
-              <a:ext cx="288000" cy="288000"/>
+              <a:off x="6296418" y="4660439"/>
+              <a:ext cx="900000" cy="900000"/>
+              <a:chOff x="6296418" y="4660439"/>
+              <a:chExt cx="900000" cy="900000"/>
             </a:xfrm>
-            <a:prstGeom prst="rect">
-              <a:avLst/>
-            </a:prstGeom>
-          </p:spPr>
-        </p:pic>
-        <p:pic>
-          <p:nvPicPr>
-            <p:cNvPr id="219" name="Graphique 1" descr="Pion avec un remplissage uni">
+          </p:grpSpPr>
+          <p:sp>
+            <p:nvSpPr>
+              <p:cNvPr id="154" name="Rectangle 153">
+                <a:extLst>
+                  <a:ext uri="{FF2B5EF4-FFF2-40B4-BE49-F238E27FC236}">
+                    <a16:creationId xmlns:a16="http://schemas.microsoft.com/office/drawing/2014/main" id="{1ECBCC94-1927-06D1-45F4-E653A80F3AF3}"/>
+                  </a:ext>
+                </a:extLst>
+              </p:cNvPr>
+              <p:cNvSpPr/>
+              <p:nvPr/>
+            </p:nvSpPr>
+            <p:spPr>
+              <a:xfrm>
+                <a:off x="6296418" y="4660439"/>
+                <a:ext cx="900000" cy="900000"/>
+              </a:xfrm>
+              <a:prstGeom prst="rect">
+                <a:avLst/>
+              </a:prstGeom>
+              <a:blipFill>
+                <a:blip r:embed="rId11"/>
+                <a:tile tx="0" ty="0" sx="100000" sy="100000" flip="none" algn="tl"/>
+              </a:blipFill>
+              <a:ln w="19050">
+                <a:solidFill>
+                  <a:schemeClr val="bg1"/>
+                </a:solidFill>
+              </a:ln>
+              <a:scene3d>
+                <a:camera prst="orthographicFront"/>
+                <a:lightRig rig="threePt" dir="t"/>
+              </a:scene3d>
+              <a:sp3d>
+                <a:bevelT/>
+              </a:sp3d>
+            </p:spPr>
+            <p:style>
+              <a:lnRef idx="2">
+                <a:schemeClr val="accent1">
+                  <a:shade val="15000"/>
+                </a:schemeClr>
+              </a:lnRef>
+              <a:fillRef idx="1">
+                <a:schemeClr val="accent1"/>
+              </a:fillRef>
+              <a:effectRef idx="0">
+                <a:schemeClr val="accent1"/>
+              </a:effectRef>
+              <a:fontRef idx="minor">
+                <a:schemeClr val="lt1"/>
+              </a:fontRef>
+            </p:style>
+            <p:txBody>
+              <a:bodyPr rot="0" spcFirstLastPara="0" vert="horz" wrap="square" lIns="91440" tIns="45720" rIns="91440" bIns="45720" numCol="1" spcCol="0" rtlCol="0" fromWordArt="0" anchor="t" anchorCtr="0" forceAA="0" compatLnSpc="1">
+                <a:prstTxWarp prst="textNoShape">
+                  <a:avLst/>
+                </a:prstTxWarp>
+                <a:noAutofit/>
+              </a:bodyPr>
+              <a:lstStyle/>
+              <a:p>
+                <a:pPr algn="ctr">
+                  <a:lnSpc>
+                    <a:spcPct val="107000"/>
+                  </a:lnSpc>
+                  <a:spcAft>
+                    <a:spcPts val="800"/>
+                  </a:spcAft>
+                  <a:buNone/>
+                </a:pPr>
+                <a:r>
+                  <a:rPr lang="fr-FR" sz="1400" b="1" dirty="0">
+                    <a:solidFill>
+                      <a:schemeClr val="tx1"/>
+                    </a:solidFill>
+                    <a:effectLst/>
+                    <a:latin typeface="Segoe UI" panose="020B0502040204020203" pitchFamily="34" charset="0"/>
+                    <a:ea typeface="Aptos" panose="020B0004020202020204" pitchFamily="34" charset="0"/>
+                    <a:cs typeface="Segoe UI" panose="020B0502040204020203" pitchFamily="34" charset="0"/>
+                  </a:rPr>
+                  <a:t>18</a:t>
+                </a:r>
+              </a:p>
+            </p:txBody>
+          </p:sp>
+          <p:pic>
+            <p:nvPicPr>
+              <p:cNvPr id="218" name="Graphique 22" descr="Pion avec un remplissage uni">
+                <a:extLst>
+                  <a:ext uri="{FF2B5EF4-FFF2-40B4-BE49-F238E27FC236}">
+                    <a16:creationId xmlns:a16="http://schemas.microsoft.com/office/drawing/2014/main" id="{EDEB36CE-ABAB-21F8-5E53-B3CE5E1E974B}"/>
+                  </a:ext>
+                </a:extLst>
+              </p:cNvPr>
+              <p:cNvPicPr>
+                <a:picLocks noChangeAspect="1"/>
+              </p:cNvPicPr>
+              <p:nvPr/>
+            </p:nvPicPr>
+            <p:blipFill>
+              <a:blip>
+                <a:extLst>
+                  <a:ext uri="{96DAC541-7B7A-43D3-8B79-37D633B846F1}">
+                    <asvg:svgBlip xmlns:asvg="http://schemas.microsoft.com/office/drawing/2016/SVG/main" r:embed="rId12"/>
+                  </a:ext>
+                </a:extLst>
+              </a:blip>
+              <a:stretch>
+                <a:fillRect/>
+              </a:stretch>
+            </p:blipFill>
+            <p:spPr>
+              <a:xfrm>
+                <a:off x="6516377" y="5226761"/>
+                <a:ext cx="288000" cy="288000"/>
+              </a:xfrm>
+              <a:prstGeom prst="rect">
+                <a:avLst/>
+              </a:prstGeom>
+            </p:spPr>
+          </p:pic>
+          <p:pic>
+            <p:nvPicPr>
+              <p:cNvPr id="219" name="Graphique 1" descr="Pion avec un remplissage uni">
+                <a:extLst>
+                  <a:ext uri="{FF2B5EF4-FFF2-40B4-BE49-F238E27FC236}">
+                    <a16:creationId xmlns:a16="http://schemas.microsoft.com/office/drawing/2014/main" id="{47795E81-6A5F-16BD-AAEA-487C95FD491C}"/>
+                  </a:ext>
+                </a:extLst>
+              </p:cNvPr>
+              <p:cNvPicPr>
+                <a:picLocks noChangeAspect="1"/>
+              </p:cNvPicPr>
+              <p:nvPr/>
+            </p:nvPicPr>
+            <p:blipFill>
+              <a:blip>
+                <a:extLst>
+                  <a:ext uri="{96DAC541-7B7A-43D3-8B79-37D633B846F1}">
+                    <asvg:svgBlip xmlns:asvg="http://schemas.microsoft.com/office/drawing/2016/SVG/main" r:embed="rId12"/>
+                  </a:ext>
+                </a:extLst>
+              </a:blip>
+              <a:stretch>
+                <a:fillRect/>
+              </a:stretch>
+            </p:blipFill>
+            <p:spPr>
+              <a:xfrm>
+                <a:off x="6702301" y="5226761"/>
+                <a:ext cx="286983" cy="288000"/>
+              </a:xfrm>
+              <a:prstGeom prst="rect">
+                <a:avLst/>
+              </a:prstGeom>
+            </p:spPr>
+          </p:pic>
+        </p:grpSp>
+        <p:grpSp>
+          <p:nvGrpSpPr>
+            <p:cNvPr id="11" name="Groupe 10">
               <a:extLst>
                 <a:ext uri="{FF2B5EF4-FFF2-40B4-BE49-F238E27FC236}">
-                  <a16:creationId xmlns:a16="http://schemas.microsoft.com/office/drawing/2014/main" id="{47795E81-6A5F-16BD-AAEA-487C95FD491C}"/>
+                  <a16:creationId xmlns:a16="http://schemas.microsoft.com/office/drawing/2014/main" id="{3B7ED9E7-0381-8ADE-1A8D-A0FBEDE26635}"/>
                 </a:ext>
               </a:extLst>
             </p:cNvPr>
-            <p:cNvPicPr>
-              <a:picLocks noChangeAspect="1"/>
-            </p:cNvPicPr>
+            <p:cNvGrpSpPr/>
             <p:nvPr/>
-          </p:nvPicPr>
-          <p:blipFill>
-            <a:blip r:embed="rId13">
-              <a:extLst>
-                <a:ext uri="{96DAC541-7B7A-43D3-8B79-37D633B846F1}">
-                  <asvg:svgBlip xmlns:asvg="http://schemas.microsoft.com/office/drawing/2016/SVG/main" r:embed="rId14"/>
-                </a:ext>
-              </a:extLst>
-            </a:blip>
-            <a:stretch>
-              <a:fillRect/>
-            </a:stretch>
-          </p:blipFill>
-          <p:spPr>
+          </p:nvGrpSpPr>
+          <p:grpSpPr>
             <a:xfrm>
-              <a:off x="6702301" y="5226761"/>
-              <a:ext cx="286983" cy="288000"/>
+              <a:off x="7435046" y="3458436"/>
+              <a:ext cx="900000" cy="900000"/>
+              <a:chOff x="7435046" y="3458436"/>
+              <a:chExt cx="900000" cy="900000"/>
             </a:xfrm>
-            <a:prstGeom prst="rect">
-              <a:avLst/>
-            </a:prstGeom>
-          </p:spPr>
-        </p:pic>
-        <p:pic>
-          <p:nvPicPr>
-            <p:cNvPr id="220" name="Graphique 1" descr="Pion avec un remplissage uni">
+          </p:grpSpPr>
+          <p:sp>
+            <p:nvSpPr>
+              <p:cNvPr id="149" name="Rectangle 148">
+                <a:extLst>
+                  <a:ext uri="{FF2B5EF4-FFF2-40B4-BE49-F238E27FC236}">
+                    <a16:creationId xmlns:a16="http://schemas.microsoft.com/office/drawing/2014/main" id="{FDB779C8-202E-B522-53A8-D7184A20C4AC}"/>
+                  </a:ext>
+                </a:extLst>
+              </p:cNvPr>
+              <p:cNvSpPr/>
+              <p:nvPr/>
+            </p:nvSpPr>
+            <p:spPr>
+              <a:xfrm>
+                <a:off x="7435046" y="3458436"/>
+                <a:ext cx="900000" cy="900000"/>
+              </a:xfrm>
+              <a:prstGeom prst="rect">
+                <a:avLst/>
+              </a:prstGeom>
+              <a:blipFill>
+                <a:blip r:embed="rId13">
+                  <a:extLst>
+                    <a:ext uri="{BEBA8EAE-BF5A-486C-A8C5-ECC9F3942E4B}">
+                      <a14:imgProps xmlns:a14="http://schemas.microsoft.com/office/drawing/2010/main">
+                        <a14:imgLayer r:embed="rId14">
+                          <a14:imgEffect>
+                            <a14:artisticPaintBrush/>
+                          </a14:imgEffect>
+                        </a14:imgLayer>
+                      </a14:imgProps>
+                    </a:ext>
+                  </a:extLst>
+                </a:blip>
+                <a:tile tx="0" ty="0" sx="100000" sy="100000" flip="none" algn="tl"/>
+              </a:blipFill>
+              <a:ln w="19050">
+                <a:solidFill>
+                  <a:schemeClr val="bg1"/>
+                </a:solidFill>
+              </a:ln>
+              <a:scene3d>
+                <a:camera prst="orthographicFront"/>
+                <a:lightRig rig="threePt" dir="t"/>
+              </a:scene3d>
+              <a:sp3d>
+                <a:bevelT/>
+              </a:sp3d>
+            </p:spPr>
+            <p:style>
+              <a:lnRef idx="2">
+                <a:schemeClr val="accent1">
+                  <a:shade val="15000"/>
+                </a:schemeClr>
+              </a:lnRef>
+              <a:fillRef idx="1">
+                <a:schemeClr val="accent1"/>
+              </a:fillRef>
+              <a:effectRef idx="0">
+                <a:schemeClr val="accent1"/>
+              </a:effectRef>
+              <a:fontRef idx="minor">
+                <a:schemeClr val="lt1"/>
+              </a:fontRef>
+            </p:style>
+            <p:txBody>
+              <a:bodyPr rot="0" spcFirstLastPara="0" vert="horz" wrap="square" lIns="91440" tIns="45720" rIns="91440" bIns="45720" numCol="1" spcCol="0" rtlCol="0" fromWordArt="0" anchor="t" anchorCtr="0" forceAA="0" compatLnSpc="1">
+                <a:prstTxWarp prst="textNoShape">
+                  <a:avLst/>
+                </a:prstTxWarp>
+                <a:noAutofit/>
+              </a:bodyPr>
+              <a:lstStyle/>
+              <a:p>
+                <a:pPr algn="ctr">
+                  <a:lnSpc>
+                    <a:spcPct val="107000"/>
+                  </a:lnSpc>
+                  <a:spcAft>
+                    <a:spcPts val="800"/>
+                  </a:spcAft>
+                  <a:buNone/>
+                </a:pPr>
+                <a:r>
+                  <a:rPr lang="fr-FR" sz="1400" b="1" dirty="0">
+                    <a:solidFill>
+                      <a:schemeClr val="tx1"/>
+                    </a:solidFill>
+                    <a:effectLst/>
+                    <a:latin typeface="Segoe UI" panose="020B0502040204020203" pitchFamily="34" charset="0"/>
+                    <a:ea typeface="Aptos" panose="020B0004020202020204" pitchFamily="34" charset="0"/>
+                    <a:cs typeface="Segoe UI" panose="020B0502040204020203" pitchFamily="34" charset="0"/>
+                  </a:rPr>
+                  <a:t>14</a:t>
+                </a:r>
+              </a:p>
+            </p:txBody>
+          </p:sp>
+          <p:pic>
+            <p:nvPicPr>
+              <p:cNvPr id="220" name="Graphique 1" descr="Pion avec un remplissage uni">
+                <a:extLst>
+                  <a:ext uri="{FF2B5EF4-FFF2-40B4-BE49-F238E27FC236}">
+                    <a16:creationId xmlns:a16="http://schemas.microsoft.com/office/drawing/2014/main" id="{392E43EA-E753-58A2-24FF-339932FA3B03}"/>
+                  </a:ext>
+                </a:extLst>
+              </p:cNvPr>
+              <p:cNvPicPr>
+                <a:picLocks noChangeAspect="1"/>
+              </p:cNvPicPr>
+              <p:nvPr/>
+            </p:nvPicPr>
+            <p:blipFill>
+              <a:blip>
+                <a:extLst>
+                  <a:ext uri="{96DAC541-7B7A-43D3-8B79-37D633B846F1}">
+                    <asvg:svgBlip xmlns:asvg="http://schemas.microsoft.com/office/drawing/2016/SVG/main" r:embed="rId12"/>
+                  </a:ext>
+                </a:extLst>
+              </a:blip>
+              <a:stretch>
+                <a:fillRect/>
+              </a:stretch>
+            </p:blipFill>
+            <p:spPr>
+              <a:xfrm>
+                <a:off x="7567773" y="4020967"/>
+                <a:ext cx="286983" cy="288000"/>
+              </a:xfrm>
+              <a:prstGeom prst="rect">
+                <a:avLst/>
+              </a:prstGeom>
+            </p:spPr>
+          </p:pic>
+          <p:pic>
+            <p:nvPicPr>
+              <p:cNvPr id="221" name="Graphique 1" descr="Pion avec un remplissage uni">
+                <a:extLst>
+                  <a:ext uri="{FF2B5EF4-FFF2-40B4-BE49-F238E27FC236}">
+                    <a16:creationId xmlns:a16="http://schemas.microsoft.com/office/drawing/2014/main" id="{A55C691A-E4AA-F119-7638-9527D5C18074}"/>
+                  </a:ext>
+                </a:extLst>
+              </p:cNvPr>
+              <p:cNvPicPr>
+                <a:picLocks noChangeAspect="1"/>
+              </p:cNvPicPr>
+              <p:nvPr/>
+            </p:nvPicPr>
+            <p:blipFill>
+              <a:blip>
+                <a:extLst>
+                  <a:ext uri="{96DAC541-7B7A-43D3-8B79-37D633B846F1}">
+                    <asvg:svgBlip xmlns:asvg="http://schemas.microsoft.com/office/drawing/2016/SVG/main" r:embed="rId12"/>
+                  </a:ext>
+                </a:extLst>
+              </a:blip>
+              <a:stretch>
+                <a:fillRect/>
+              </a:stretch>
+            </p:blipFill>
+            <p:spPr>
+              <a:xfrm>
+                <a:off x="7742600" y="4020967"/>
+                <a:ext cx="288000" cy="288000"/>
+              </a:xfrm>
+              <a:prstGeom prst="rect">
+                <a:avLst/>
+              </a:prstGeom>
+            </p:spPr>
+          </p:pic>
+          <p:pic>
+            <p:nvPicPr>
+              <p:cNvPr id="222" name="Graphique 1" descr="Pion avec un remplissage uni">
+                <a:extLst>
+                  <a:ext uri="{FF2B5EF4-FFF2-40B4-BE49-F238E27FC236}">
+                    <a16:creationId xmlns:a16="http://schemas.microsoft.com/office/drawing/2014/main" id="{912F4CF0-7D46-F5F6-E0E5-8389200CB2CD}"/>
+                  </a:ext>
+                </a:extLst>
+              </p:cNvPr>
+              <p:cNvPicPr>
+                <a:picLocks noChangeAspect="1"/>
+              </p:cNvPicPr>
+              <p:nvPr/>
+            </p:nvPicPr>
+            <p:blipFill>
+              <a:blip>
+                <a:extLst>
+                  <a:ext uri="{96DAC541-7B7A-43D3-8B79-37D633B846F1}">
+                    <asvg:svgBlip xmlns:asvg="http://schemas.microsoft.com/office/drawing/2016/SVG/main" r:embed="rId12"/>
+                  </a:ext>
+                </a:extLst>
+              </a:blip>
+              <a:stretch>
+                <a:fillRect/>
+              </a:stretch>
+            </p:blipFill>
+            <p:spPr>
+              <a:xfrm>
+                <a:off x="7918445" y="4020967"/>
+                <a:ext cx="288000" cy="288000"/>
+              </a:xfrm>
+              <a:prstGeom prst="rect">
+                <a:avLst/>
+              </a:prstGeom>
+            </p:spPr>
+          </p:pic>
+        </p:grpSp>
+        <p:grpSp>
+          <p:nvGrpSpPr>
+            <p:cNvPr id="9" name="Groupe 8">
               <a:extLst>
                 <a:ext uri="{FF2B5EF4-FFF2-40B4-BE49-F238E27FC236}">
-                  <a16:creationId xmlns:a16="http://schemas.microsoft.com/office/drawing/2014/main" id="{392E43EA-E753-58A2-24FF-339932FA3B03}"/>
+                  <a16:creationId xmlns:a16="http://schemas.microsoft.com/office/drawing/2014/main" id="{57F7A2D6-1B16-B339-D98A-41279154D127}"/>
                 </a:ext>
               </a:extLst>
             </p:cNvPr>
-            <p:cNvPicPr>
-              <a:picLocks noChangeAspect="1"/>
-            </p:cNvPicPr>
+            <p:cNvGrpSpPr/>
             <p:nvPr/>
-          </p:nvPicPr>
-          <p:blipFill>
-            <a:blip r:embed="rId13">
-              <a:extLst>
-                <a:ext uri="{96DAC541-7B7A-43D3-8B79-37D633B846F1}">
-                  <asvg:svgBlip xmlns:asvg="http://schemas.microsoft.com/office/drawing/2016/SVG/main" r:embed="rId14"/>
-                </a:ext>
-              </a:extLst>
-            </a:blip>
-            <a:stretch>
-              <a:fillRect/>
-            </a:stretch>
-          </p:blipFill>
-          <p:spPr>
+          </p:nvGrpSpPr>
+          <p:grpSpPr>
             <a:xfrm>
-              <a:off x="7567773" y="4020967"/>
-              <a:ext cx="286983" cy="288000"/>
+              <a:off x="5135159" y="3458436"/>
+              <a:ext cx="900000" cy="900000"/>
+              <a:chOff x="5135159" y="3458436"/>
+              <a:chExt cx="900000" cy="900000"/>
             </a:xfrm>
-            <a:prstGeom prst="rect">
-              <a:avLst/>
-            </a:prstGeom>
-          </p:spPr>
-        </p:pic>
-        <p:pic>
-          <p:nvPicPr>
-            <p:cNvPr id="221" name="Graphique 1" descr="Pion avec un remplissage uni">
-              <a:extLst>
-                <a:ext uri="{FF2B5EF4-FFF2-40B4-BE49-F238E27FC236}">
-                  <a16:creationId xmlns:a16="http://schemas.microsoft.com/office/drawing/2014/main" id="{A55C691A-E4AA-F119-7638-9527D5C18074}"/>
-                </a:ext>
-              </a:extLst>
-            </p:cNvPr>
-            <p:cNvPicPr>
-              <a:picLocks noChangeAspect="1"/>
-            </p:cNvPicPr>
-            <p:nvPr/>
-          </p:nvPicPr>
-          <p:blipFill>
-            <a:blip r:embed="rId13">
-              <a:extLst>
-                <a:ext uri="{96DAC541-7B7A-43D3-8B79-37D633B846F1}">
-                  <asvg:svgBlip xmlns:asvg="http://schemas.microsoft.com/office/drawing/2016/SVG/main" r:embed="rId14"/>
-                </a:ext>
-              </a:extLst>
-            </a:blip>
-            <a:stretch>
-              <a:fillRect/>
-            </a:stretch>
-          </p:blipFill>
-          <p:spPr>
-            <a:xfrm>
-              <a:off x="7742600" y="4020967"/>
-              <a:ext cx="288000" cy="288000"/>
-            </a:xfrm>
-            <a:prstGeom prst="rect">
-              <a:avLst/>
-            </a:prstGeom>
-          </p:spPr>
-        </p:pic>
-        <p:pic>
-          <p:nvPicPr>
-            <p:cNvPr id="222" name="Graphique 1" descr="Pion avec un remplissage uni">
-              <a:extLst>
-                <a:ext uri="{FF2B5EF4-FFF2-40B4-BE49-F238E27FC236}">
-                  <a16:creationId xmlns:a16="http://schemas.microsoft.com/office/drawing/2014/main" id="{912F4CF0-7D46-F5F6-E0E5-8389200CB2CD}"/>
-                </a:ext>
-              </a:extLst>
-            </p:cNvPr>
-            <p:cNvPicPr>
-              <a:picLocks noChangeAspect="1"/>
-            </p:cNvPicPr>
-            <p:nvPr/>
-          </p:nvPicPr>
-          <p:blipFill>
-            <a:blip r:embed="rId13">
-              <a:extLst>
-                <a:ext uri="{96DAC541-7B7A-43D3-8B79-37D633B846F1}">
-                  <asvg:svgBlip xmlns:asvg="http://schemas.microsoft.com/office/drawing/2016/SVG/main" r:embed="rId14"/>
-                </a:ext>
-              </a:extLst>
-            </a:blip>
-            <a:stretch>
-              <a:fillRect/>
-            </a:stretch>
-          </p:blipFill>
-          <p:spPr>
-            <a:xfrm>
-              <a:off x="7918445" y="4020967"/>
-              <a:ext cx="288000" cy="288000"/>
-            </a:xfrm>
-            <a:prstGeom prst="rect">
-              <a:avLst/>
-            </a:prstGeom>
-          </p:spPr>
-        </p:pic>
-        <p:pic>
-          <p:nvPicPr>
-            <p:cNvPr id="223" name="Graphique 1" descr="Pion avec un remplissage uni">
-              <a:extLst>
-                <a:ext uri="{FF2B5EF4-FFF2-40B4-BE49-F238E27FC236}">
-                  <a16:creationId xmlns:a16="http://schemas.microsoft.com/office/drawing/2014/main" id="{8F0276D8-F6F7-3402-EC36-628726E362AF}"/>
-                </a:ext>
-              </a:extLst>
-            </p:cNvPr>
-            <p:cNvPicPr>
-              <a:picLocks noChangeAspect="1"/>
-            </p:cNvPicPr>
-            <p:nvPr/>
-          </p:nvPicPr>
-          <p:blipFill>
-            <a:blip r:embed="rId13">
-              <a:extLst>
-                <a:ext uri="{96DAC541-7B7A-43D3-8B79-37D633B846F1}">
-                  <asvg:svgBlip xmlns:asvg="http://schemas.microsoft.com/office/drawing/2016/SVG/main" r:embed="rId14"/>
-                </a:ext>
-              </a:extLst>
-            </a:blip>
-            <a:stretch>
-              <a:fillRect/>
-            </a:stretch>
-          </p:blipFill>
-          <p:spPr>
-            <a:xfrm>
-              <a:off x="5158676" y="4020967"/>
-              <a:ext cx="288000" cy="288000"/>
-            </a:xfrm>
-            <a:prstGeom prst="rect">
-              <a:avLst/>
-            </a:prstGeom>
-          </p:spPr>
-        </p:pic>
-        <p:pic>
-          <p:nvPicPr>
-            <p:cNvPr id="224" name="Graphique 1" descr="Pion avec un remplissage uni">
-              <a:extLst>
-                <a:ext uri="{FF2B5EF4-FFF2-40B4-BE49-F238E27FC236}">
-                  <a16:creationId xmlns:a16="http://schemas.microsoft.com/office/drawing/2014/main" id="{8710D397-5FD4-FAC4-4FB0-E6E3815B0518}"/>
-                </a:ext>
-              </a:extLst>
-            </p:cNvPr>
-            <p:cNvPicPr>
-              <a:picLocks noChangeAspect="1"/>
-            </p:cNvPicPr>
-            <p:nvPr/>
-          </p:nvPicPr>
-          <p:blipFill>
-            <a:blip r:embed="rId13">
-              <a:extLst>
-                <a:ext uri="{96DAC541-7B7A-43D3-8B79-37D633B846F1}">
-                  <asvg:svgBlip xmlns:asvg="http://schemas.microsoft.com/office/drawing/2016/SVG/main" r:embed="rId14"/>
-                </a:ext>
-              </a:extLst>
-            </a:blip>
-            <a:stretch>
-              <a:fillRect/>
-            </a:stretch>
-          </p:blipFill>
-          <p:spPr>
-            <a:xfrm>
-              <a:off x="5521749" y="4020967"/>
-              <a:ext cx="289025" cy="288000"/>
-            </a:xfrm>
-            <a:prstGeom prst="rect">
-              <a:avLst/>
-            </a:prstGeom>
-          </p:spPr>
-        </p:pic>
-        <p:pic>
-          <p:nvPicPr>
-            <p:cNvPr id="225" name="Graphique 1" descr="Pion avec un remplissage uni">
-              <a:extLst>
-                <a:ext uri="{FF2B5EF4-FFF2-40B4-BE49-F238E27FC236}">
-                  <a16:creationId xmlns:a16="http://schemas.microsoft.com/office/drawing/2014/main" id="{C253AB74-EA8C-F1F7-FB8A-C16CBFE45733}"/>
-                </a:ext>
-              </a:extLst>
-            </p:cNvPr>
-            <p:cNvPicPr>
-              <a:picLocks noChangeAspect="1"/>
-            </p:cNvPicPr>
-            <p:nvPr/>
-          </p:nvPicPr>
-          <p:blipFill>
-            <a:blip r:embed="rId13">
-              <a:extLst>
-                <a:ext uri="{96DAC541-7B7A-43D3-8B79-37D633B846F1}">
-                  <asvg:svgBlip xmlns:asvg="http://schemas.microsoft.com/office/drawing/2016/SVG/main" r:embed="rId14"/>
-                </a:ext>
-              </a:extLst>
-            </a:blip>
-            <a:stretch>
-              <a:fillRect/>
-            </a:stretch>
-          </p:blipFill>
-          <p:spPr>
-            <a:xfrm>
-              <a:off x="5339700" y="4020967"/>
-              <a:ext cx="289025" cy="288000"/>
-            </a:xfrm>
-            <a:prstGeom prst="rect">
-              <a:avLst/>
-            </a:prstGeom>
-          </p:spPr>
-        </p:pic>
-        <p:pic>
-          <p:nvPicPr>
-            <p:cNvPr id="226" name="Graphique 1" descr="Pion avec un remplissage uni">
-              <a:extLst>
-                <a:ext uri="{FF2B5EF4-FFF2-40B4-BE49-F238E27FC236}">
-                  <a16:creationId xmlns:a16="http://schemas.microsoft.com/office/drawing/2014/main" id="{8105F1DC-4B3D-8C60-341E-96DF864931BD}"/>
-                </a:ext>
-              </a:extLst>
-            </p:cNvPr>
-            <p:cNvPicPr>
-              <a:picLocks noChangeAspect="1"/>
-            </p:cNvPicPr>
-            <p:nvPr/>
-          </p:nvPicPr>
-          <p:blipFill>
-            <a:blip r:embed="rId13">
-              <a:extLst>
-                <a:ext uri="{96DAC541-7B7A-43D3-8B79-37D633B846F1}">
-                  <asvg:svgBlip xmlns:asvg="http://schemas.microsoft.com/office/drawing/2016/SVG/main" r:embed="rId14"/>
-                </a:ext>
-              </a:extLst>
-            </a:blip>
-            <a:stretch>
-              <a:fillRect/>
-            </a:stretch>
-          </p:blipFill>
-          <p:spPr>
-            <a:xfrm>
-              <a:off x="5703797" y="4020967"/>
-              <a:ext cx="290057" cy="288000"/>
-            </a:xfrm>
-            <a:prstGeom prst="rect">
-              <a:avLst/>
-            </a:prstGeom>
-          </p:spPr>
-        </p:pic>
+          </p:grpSpPr>
+          <p:sp>
+            <p:nvSpPr>
+              <p:cNvPr id="147" name="Rectangle 146">
+                <a:extLst>
+                  <a:ext uri="{FF2B5EF4-FFF2-40B4-BE49-F238E27FC236}">
+                    <a16:creationId xmlns:a16="http://schemas.microsoft.com/office/drawing/2014/main" id="{993696D2-AB5B-AFF5-5984-623544EDEF1B}"/>
+                  </a:ext>
+                </a:extLst>
+              </p:cNvPr>
+              <p:cNvSpPr/>
+              <p:nvPr/>
+            </p:nvSpPr>
+            <p:spPr>
+              <a:xfrm>
+                <a:off x="5135159" y="3458436"/>
+                <a:ext cx="900000" cy="900000"/>
+              </a:xfrm>
+              <a:prstGeom prst="rect">
+                <a:avLst/>
+              </a:prstGeom>
+              <a:blipFill>
+                <a:blip r:embed="rId13">
+                  <a:extLst>
+                    <a:ext uri="{BEBA8EAE-BF5A-486C-A8C5-ECC9F3942E4B}">
+                      <a14:imgProps xmlns:a14="http://schemas.microsoft.com/office/drawing/2010/main">
+                        <a14:imgLayer r:embed="rId14">
+                          <a14:imgEffect>
+                            <a14:artisticPaintBrush/>
+                          </a14:imgEffect>
+                        </a14:imgLayer>
+                      </a14:imgProps>
+                    </a:ext>
+                  </a:extLst>
+                </a:blip>
+                <a:tile tx="0" ty="0" sx="100000" sy="100000" flip="none" algn="tl"/>
+              </a:blipFill>
+              <a:ln w="19050">
+                <a:solidFill>
+                  <a:schemeClr val="bg1"/>
+                </a:solidFill>
+              </a:ln>
+              <a:scene3d>
+                <a:camera prst="orthographicFront"/>
+                <a:lightRig rig="threePt" dir="t"/>
+              </a:scene3d>
+              <a:sp3d>
+                <a:bevelT/>
+              </a:sp3d>
+            </p:spPr>
+            <p:style>
+              <a:lnRef idx="2">
+                <a:schemeClr val="accent1">
+                  <a:shade val="15000"/>
+                </a:schemeClr>
+              </a:lnRef>
+              <a:fillRef idx="1">
+                <a:schemeClr val="accent1"/>
+              </a:fillRef>
+              <a:effectRef idx="0">
+                <a:schemeClr val="accent1"/>
+              </a:effectRef>
+              <a:fontRef idx="minor">
+                <a:schemeClr val="lt1"/>
+              </a:fontRef>
+            </p:style>
+            <p:txBody>
+              <a:bodyPr rot="0" spcFirstLastPara="0" vert="horz" wrap="square" lIns="91440" tIns="45720" rIns="91440" bIns="45720" numCol="1" spcCol="0" rtlCol="0" fromWordArt="0" anchor="t" anchorCtr="0" forceAA="0" compatLnSpc="1">
+                <a:prstTxWarp prst="textNoShape">
+                  <a:avLst/>
+                </a:prstTxWarp>
+                <a:noAutofit/>
+              </a:bodyPr>
+              <a:lstStyle/>
+              <a:p>
+                <a:pPr algn="ctr">
+                  <a:lnSpc>
+                    <a:spcPct val="107000"/>
+                  </a:lnSpc>
+                  <a:spcAft>
+                    <a:spcPts val="800"/>
+                  </a:spcAft>
+                  <a:buNone/>
+                </a:pPr>
+                <a:r>
+                  <a:rPr lang="fr-FR" sz="1400" b="1" dirty="0">
+                    <a:solidFill>
+                      <a:schemeClr val="tx1"/>
+                    </a:solidFill>
+                    <a:effectLst/>
+                    <a:latin typeface="Segoe UI" panose="020B0502040204020203" pitchFamily="34" charset="0"/>
+                    <a:ea typeface="Aptos" panose="020B0004020202020204" pitchFamily="34" charset="0"/>
+                    <a:cs typeface="Segoe UI" panose="020B0502040204020203" pitchFamily="34" charset="0"/>
+                  </a:rPr>
+                  <a:t>12</a:t>
+                </a:r>
+              </a:p>
+            </p:txBody>
+          </p:sp>
+          <p:pic>
+            <p:nvPicPr>
+              <p:cNvPr id="223" name="Graphique 1" descr="Pion avec un remplissage uni">
+                <a:extLst>
+                  <a:ext uri="{FF2B5EF4-FFF2-40B4-BE49-F238E27FC236}">
+                    <a16:creationId xmlns:a16="http://schemas.microsoft.com/office/drawing/2014/main" id="{8F0276D8-F6F7-3402-EC36-628726E362AF}"/>
+                  </a:ext>
+                </a:extLst>
+              </p:cNvPr>
+              <p:cNvPicPr>
+                <a:picLocks noChangeAspect="1"/>
+              </p:cNvPicPr>
+              <p:nvPr/>
+            </p:nvPicPr>
+            <p:blipFill>
+              <a:blip>
+                <a:extLst>
+                  <a:ext uri="{96DAC541-7B7A-43D3-8B79-37D633B846F1}">
+                    <asvg:svgBlip xmlns:asvg="http://schemas.microsoft.com/office/drawing/2016/SVG/main" r:embed="rId12"/>
+                  </a:ext>
+                </a:extLst>
+              </a:blip>
+              <a:stretch>
+                <a:fillRect/>
+              </a:stretch>
+            </p:blipFill>
+            <p:spPr>
+              <a:xfrm>
+                <a:off x="5158676" y="4020967"/>
+                <a:ext cx="288000" cy="288000"/>
+              </a:xfrm>
+              <a:prstGeom prst="rect">
+                <a:avLst/>
+              </a:prstGeom>
+            </p:spPr>
+          </p:pic>
+          <p:pic>
+            <p:nvPicPr>
+              <p:cNvPr id="224" name="Graphique 1" descr="Pion avec un remplissage uni">
+                <a:extLst>
+                  <a:ext uri="{FF2B5EF4-FFF2-40B4-BE49-F238E27FC236}">
+                    <a16:creationId xmlns:a16="http://schemas.microsoft.com/office/drawing/2014/main" id="{8710D397-5FD4-FAC4-4FB0-E6E3815B0518}"/>
+                  </a:ext>
+                </a:extLst>
+              </p:cNvPr>
+              <p:cNvPicPr>
+                <a:picLocks noChangeAspect="1"/>
+              </p:cNvPicPr>
+              <p:nvPr/>
+            </p:nvPicPr>
+            <p:blipFill>
+              <a:blip>
+                <a:extLst>
+                  <a:ext uri="{96DAC541-7B7A-43D3-8B79-37D633B846F1}">
+                    <asvg:svgBlip xmlns:asvg="http://schemas.microsoft.com/office/drawing/2016/SVG/main" r:embed="rId12"/>
+                  </a:ext>
+                </a:extLst>
+              </a:blip>
+              <a:stretch>
+                <a:fillRect/>
+              </a:stretch>
+            </p:blipFill>
+            <p:spPr>
+              <a:xfrm>
+                <a:off x="5521749" y="4020967"/>
+                <a:ext cx="289025" cy="288000"/>
+              </a:xfrm>
+              <a:prstGeom prst="rect">
+                <a:avLst/>
+              </a:prstGeom>
+            </p:spPr>
+          </p:pic>
+          <p:pic>
+            <p:nvPicPr>
+              <p:cNvPr id="225" name="Graphique 1" descr="Pion avec un remplissage uni">
+                <a:extLst>
+                  <a:ext uri="{FF2B5EF4-FFF2-40B4-BE49-F238E27FC236}">
+                    <a16:creationId xmlns:a16="http://schemas.microsoft.com/office/drawing/2014/main" id="{C253AB74-EA8C-F1F7-FB8A-C16CBFE45733}"/>
+                  </a:ext>
+                </a:extLst>
+              </p:cNvPr>
+              <p:cNvPicPr>
+                <a:picLocks noChangeAspect="1"/>
+              </p:cNvPicPr>
+              <p:nvPr/>
+            </p:nvPicPr>
+            <p:blipFill>
+              <a:blip>
+                <a:extLst>
+                  <a:ext uri="{96DAC541-7B7A-43D3-8B79-37D633B846F1}">
+                    <asvg:svgBlip xmlns:asvg="http://schemas.microsoft.com/office/drawing/2016/SVG/main" r:embed="rId12"/>
+                  </a:ext>
+                </a:extLst>
+              </a:blip>
+              <a:stretch>
+                <a:fillRect/>
+              </a:stretch>
+            </p:blipFill>
+            <p:spPr>
+              <a:xfrm>
+                <a:off x="5339700" y="4020967"/>
+                <a:ext cx="289025" cy="288000"/>
+              </a:xfrm>
+              <a:prstGeom prst="rect">
+                <a:avLst/>
+              </a:prstGeom>
+            </p:spPr>
+          </p:pic>
+          <p:pic>
+            <p:nvPicPr>
+              <p:cNvPr id="226" name="Graphique 1" descr="Pion avec un remplissage uni">
+                <a:extLst>
+                  <a:ext uri="{FF2B5EF4-FFF2-40B4-BE49-F238E27FC236}">
+                    <a16:creationId xmlns:a16="http://schemas.microsoft.com/office/drawing/2014/main" id="{8105F1DC-4B3D-8C60-341E-96DF864931BD}"/>
+                  </a:ext>
+                </a:extLst>
+              </p:cNvPr>
+              <p:cNvPicPr>
+                <a:picLocks noChangeAspect="1"/>
+              </p:cNvPicPr>
+              <p:nvPr/>
+            </p:nvPicPr>
+            <p:blipFill>
+              <a:blip>
+                <a:extLst>
+                  <a:ext uri="{96DAC541-7B7A-43D3-8B79-37D633B846F1}">
+                    <asvg:svgBlip xmlns:asvg="http://schemas.microsoft.com/office/drawing/2016/SVG/main" r:embed="rId12"/>
+                  </a:ext>
+                </a:extLst>
+              </a:blip>
+              <a:stretch>
+                <a:fillRect/>
+              </a:stretch>
+            </p:blipFill>
+            <p:spPr>
+              <a:xfrm>
+                <a:off x="5703797" y="4020967"/>
+                <a:ext cx="290057" cy="288000"/>
+              </a:xfrm>
+              <a:prstGeom prst="rect">
+                <a:avLst/>
+              </a:prstGeom>
+            </p:spPr>
+          </p:pic>
+        </p:grpSp>
         <p:sp>
           <p:nvSpPr>
             <p:cNvPr id="228" name="ZoneTexte 227">
@@ -7367,18 +7514,18 @@
           </p:nvSpPr>
           <p:spPr>
             <a:xfrm>
-              <a:off x="2523458" y="4787273"/>
-              <a:ext cx="1280381" cy="646331"/>
+              <a:off x="2431436" y="4216741"/>
+              <a:ext cx="1349922" cy="646331"/>
             </a:xfrm>
             <a:prstGeom prst="rect">
               <a:avLst/>
             </a:prstGeom>
             <a:blipFill>
-              <a:blip r:embed="rId10">
+              <a:blip r:embed="rId13">
                 <a:extLst>
                   <a:ext uri="{BEBA8EAE-BF5A-486C-A8C5-ECC9F3942E4B}">
                     <a14:imgProps xmlns:a14="http://schemas.microsoft.com/office/drawing/2010/main">
-                      <a14:imgLayer r:embed="rId11">
+                      <a14:imgLayer r:embed="rId14">
                         <a14:imgEffect>
                           <a14:artisticPaintBrush/>
                         </a14:imgEffect>
@@ -7458,6 +7605,113 @@
                 <a:latin typeface="Segoe UI" panose="020B0502040204020203" pitchFamily="34" charset="0"/>
                 <a:cs typeface="Segoe UI" panose="020B0502040204020203" pitchFamily="34" charset="0"/>
               </a:endParaRPr>
+            </a:p>
+          </p:txBody>
+        </p:sp>
+        <p:sp>
+          <p:nvSpPr>
+            <p:cNvPr id="7" name="ZoneTexte 6">
+              <a:extLst>
+                <a:ext uri="{FF2B5EF4-FFF2-40B4-BE49-F238E27FC236}">
+                  <a16:creationId xmlns:a16="http://schemas.microsoft.com/office/drawing/2014/main" id="{B0E31BB3-EE75-42CB-4F87-098EBC97F41F}"/>
+                </a:ext>
+              </a:extLst>
+            </p:cNvPr>
+            <p:cNvSpPr txBox="1"/>
+            <p:nvPr/>
+          </p:nvSpPr>
+          <p:spPr>
+            <a:xfrm>
+              <a:off x="2431436" y="4969052"/>
+              <a:ext cx="1349922" cy="646331"/>
+            </a:xfrm>
+            <a:prstGeom prst="rect">
+              <a:avLst/>
+            </a:prstGeom>
+            <a:blipFill>
+              <a:blip r:embed="rId13">
+                <a:extLst>
+                  <a:ext uri="{BEBA8EAE-BF5A-486C-A8C5-ECC9F3942E4B}">
+                    <a14:imgProps xmlns:a14="http://schemas.microsoft.com/office/drawing/2010/main">
+                      <a14:imgLayer r:embed="rId14">
+                        <a14:imgEffect>
+                          <a14:artisticPaintBrush/>
+                        </a14:imgEffect>
+                      </a14:imgLayer>
+                    </a14:imgProps>
+                  </a:ext>
+                </a:extLst>
+              </a:blip>
+              <a:tile tx="0" ty="0" sx="100000" sy="100000" flip="none" algn="tl"/>
+            </a:blipFill>
+            <a:ln>
+              <a:solidFill>
+                <a:schemeClr val="tx1"/>
+              </a:solidFill>
+            </a:ln>
+            <a:scene3d>
+              <a:camera prst="orthographicFront"/>
+              <a:lightRig rig="threePt" dir="t"/>
+            </a:scene3d>
+            <a:sp3d>
+              <a:bevelT/>
+            </a:sp3d>
+          </p:spPr>
+          <p:txBody>
+            <a:bodyPr wrap="square" rtlCol="0">
+              <a:spAutoFit/>
+            </a:bodyPr>
+            <a:lstStyle/>
+            <a:p>
+              <a:r>
+                <a:rPr lang="fr-FR" sz="1200" b="1" dirty="0">
+                  <a:latin typeface="Segoe UI" panose="020B0502040204020203" pitchFamily="34" charset="0"/>
+                  <a:cs typeface="Segoe UI" panose="020B0502040204020203" pitchFamily="34" charset="0"/>
+                </a:rPr>
+                <a:t>Fin de tour avec </a:t>
+              </a:r>
+              <a:r>
+                <a:rPr lang="fr-FR" sz="1200" b="1" dirty="0">
+                  <a:solidFill>
+                    <a:srgbClr val="FF0000"/>
+                  </a:solidFill>
+                  <a:latin typeface="Segoe UI" panose="020B0502040204020203" pitchFamily="34" charset="0"/>
+                  <a:cs typeface="Segoe UI" panose="020B0502040204020203" pitchFamily="34" charset="0"/>
+                </a:rPr>
+                <a:t>5 calamités </a:t>
+              </a:r>
+              <a:r>
+                <a:rPr lang="fr-FR" sz="1200" b="1" dirty="0">
+                  <a:latin typeface="Segoe UI" panose="020B0502040204020203" pitchFamily="34" charset="0"/>
+                  <a:cs typeface="Segoe UI" panose="020B0502040204020203" pitchFamily="34" charset="0"/>
+                </a:rPr>
+                <a:t>ou plus </a:t>
+              </a:r>
+              <a:r>
+                <a:rPr lang="fr-FR" sz="1200" b="1" dirty="0">
+                  <a:latin typeface="Segoe UI" panose="020B0502040204020203" pitchFamily="34" charset="0"/>
+                  <a:cs typeface="Segoe UI" panose="020B0502040204020203" pitchFamily="34" charset="0"/>
+                  <a:sym typeface="Wingdings" panose="05000000000000000000" pitchFamily="2" charset="2"/>
+                </a:rPr>
+                <a:t></a:t>
+              </a:r>
+              <a:r>
+                <a:rPr lang="fr-FR" sz="1200" b="1" dirty="0">
+                  <a:latin typeface="Segoe UI" panose="020B0502040204020203" pitchFamily="34" charset="0"/>
+                  <a:cs typeface="Segoe UI" panose="020B0502040204020203" pitchFamily="34" charset="0"/>
+                </a:rPr>
+                <a:t> </a:t>
+              </a:r>
+              <a:r>
+                <a:rPr lang="fr-FR" sz="1200" b="1" dirty="0">
+                  <a:solidFill>
+                    <a:srgbClr val="FF0000"/>
+                  </a:solidFill>
+                  <a:latin typeface="Segoe UI" panose="020B0502040204020203" pitchFamily="34" charset="0"/>
+                  <a:cs typeface="Segoe UI" panose="020B0502040204020203" pitchFamily="34" charset="0"/>
+                </a:rPr>
+                <a:t>STOP</a:t>
+              </a:r>
             </a:p>
           </p:txBody>
         </p:sp>

</xml_diff>